<commit_message>
added ruff section and recompiled
</commit_message>
<xml_diff>
--- a/Programming01/Session03/slides.pptx
+++ b/Programming01/Session03/slides.pptx
@@ -5,7 +5,7 @@
     <p:sldMasterId id="2147483648" r:id="rId1"/>
   </p:sldMasterIdLst>
   <p:notesMasterIdLst>
-    <p:notesMasterId r:id="rId20"/>
+    <p:notesMasterId r:id="rId24"/>
   </p:notesMasterIdLst>
   <p:sldIdLst>
     <p:sldId id="256" r:id="rId2"/>
@@ -26,6 +26,10 @@
     <p:sldId id="271" r:id="rId17"/>
     <p:sldId id="272" r:id="rId18"/>
     <p:sldId id="273" r:id="rId19"/>
+    <p:sldId id="274" r:id="rId20"/>
+    <p:sldId id="275" r:id="rId21"/>
+    <p:sldId id="276" r:id="rId22"/>
+    <p:sldId id="277" r:id="rId23"/>
   </p:sldIdLst>
   <p:sldSz cx="9144000" cy="5143500" type="screen16x9"/>
   <p:notesSz cx="6858000" cy="9144000"/>
@@ -1234,6 +1238,670 @@
             <a:fld id="{18BDFEC3-8487-43E8-A154-7C12CBC1FFF2}" type="slidenum">
               <a:rPr lang="en-US"/>
               <a:t>18</a:t>
+            </a:fld>
+            <a:endParaRPr lang="en-US"/>
+          </a:p>
+        </p:txBody>
+      </p:sp>
+    </p:spTree>
+  </p:cSld>
+</p:notes>
+</file>
+
+<file path=ppt/notesSlides/notesSlide15.xml><?xml version="1.0" encoding="utf-8"?>
+<p:notes xmlns:a="http://schemas.openxmlformats.org/drawingml/2006/main" xmlns:r="http://schemas.openxmlformats.org/officeDocument/2006/relationships" xmlns:p="http://schemas.openxmlformats.org/presentationml/2006/main">
+  <p:cSld>
+    <p:spTree>
+      <p:nvGrpSpPr>
+        <p:cNvPr id="1" name=""/>
+        <p:cNvGrpSpPr/>
+        <p:nvPr/>
+      </p:nvGrpSpPr>
+      <p:grpSpPr>
+        <a:xfrm>
+          <a:off x="0" y="0"/>
+          <a:ext cx="0" cy="0"/>
+          <a:chOff x="0" y="0"/>
+          <a:chExt cx="0" cy="0"/>
+        </a:xfrm>
+      </p:grpSpPr>
+      <p:sp>
+        <p:nvSpPr>
+          <p:cNvPr id="2" name="Slide Image Placeholder 1"/>
+          <p:cNvSpPr>
+            <a:spLocks noGrp="1" noRot="1" noChangeAspect="1"/>
+          </p:cNvSpPr>
+          <p:nvPr>
+            <p:ph type="sldImg"/>
+          </p:nvPr>
+        </p:nvSpPr>
+        <p:spPr/>
+      </p:sp>
+      <p:sp>
+        <p:nvSpPr>
+          <p:cNvPr id="3" name="Notes Placeholder 2"/>
+          <p:cNvSpPr>
+            <a:spLocks noGrp="1"/>
+          </p:cNvSpPr>
+          <p:nvPr>
+            <p:ph type="body" idx="1"/>
+          </p:nvPr>
+        </p:nvSpPr>
+        <p:spPr/>
+        <p:txBody>
+          <a:bodyPr/>
+          <a:lstStyle/>
+          <a:p>
+            <a:pPr lvl="0" indent="0" marL="0">
+              <a:buNone/>
+            </a:pPr>
+            <a:r>
+              <a:rPr>
+                <a:latin typeface="Courier"/>
+              </a:rPr>
+              <a:t>ruff</a:t>
+            </a:r>
+            <a:r>
+              <a:rPr/>
+              <a:t> is a formatter </a:t>
+            </a:r>
+            <a:r>
+              <a:rPr i="1"/>
+              <a:t>and</a:t>
+            </a:r>
+            <a:r>
+              <a:rPr/>
+              <a:t> a linter for Python, from the same people as </a:t>
+            </a:r>
+            <a:r>
+              <a:rPr>
+                <a:latin typeface="Courier"/>
+              </a:rPr>
+              <a:t>uv</a:t>
+            </a:r>
+            <a:r>
+              <a:rPr/>
+              <a:t>, so it installs the same way and runs just as fast (a whole project in well under a second). Two jobs, worth separating in their heads: (1) the formatter rewrites the layout of your code: indentation, quotes, line breaks, spaces around operators. It never changes what the code does. (2) the linter reads the code and reports mistakes: an unused import, a variable assigned and never read, a name that does not exist. Why bother in a health-data project? Because a diff should show what you changed, not who reformatted it. With a formatter, </a:t>
+            </a:r>
+            <a:r>
+              <a:rPr>
+                <a:latin typeface="Courier"/>
+              </a:rPr>
+              <a:t>git diff</a:t>
+            </a:r>
+            <a:r>
+              <a:rPr/>
+              <a:t> contains only real changes, and code review stops being an argument about spaces. Note </a:t>
+            </a:r>
+            <a:r>
+              <a:rPr>
+                <a:latin typeface="Courier"/>
+              </a:rPr>
+              <a:t>uv add --dev ruff</a:t>
+            </a:r>
+            <a:r>
+              <a:rPr/>
+              <a:t>: it is a development tool, not a dependency of the analysis, so it belongs in the dev group of </a:t>
+            </a:r>
+            <a:r>
+              <a:rPr>
+                <a:latin typeface="Courier"/>
+              </a:rPr>
+              <a:t>pyproject.toml</a:t>
+            </a:r>
+            <a:r>
+              <a:rPr/>
+              <a:t>. If </a:t>
+            </a:r>
+            <a:r>
+              <a:rPr>
+                <a:latin typeface="Courier"/>
+              </a:rPr>
+              <a:t>ruff</a:t>
+            </a:r>
+            <a:r>
+              <a:rPr/>
+              <a:t> is not on the path, run it through uv: </a:t>
+            </a:r>
+            <a:r>
+              <a:rPr>
+                <a:latin typeface="Courier"/>
+              </a:rPr>
+              <a:t>uv run ruff --version</a:t>
+            </a:r>
+            <a:r>
+              <a:rPr/>
+              <a:t>.</a:t>
+            </a:r>
+          </a:p>
+        </p:txBody>
+      </p:sp>
+      <p:sp>
+        <p:nvSpPr>
+          <p:cNvPr id="4" name="Slide Number Placeholder 3"/>
+          <p:cNvSpPr>
+            <a:spLocks noGrp="1"/>
+          </p:cNvSpPr>
+          <p:nvPr>
+            <p:ph type="sldNum" sz="quarter" idx="10"/>
+          </p:nvPr>
+        </p:nvSpPr>
+        <p:spPr/>
+        <p:txBody>
+          <a:bodyPr/>
+          <a:lstStyle/>
+          <a:p>
+            <a:fld id="{18BDFEC3-8487-43E8-A154-7C12CBC1FFF2}" type="slidenum">
+              <a:rPr lang="en-US"/>
+              <a:t>20</a:t>
+            </a:fld>
+            <a:endParaRPr lang="en-US"/>
+          </a:p>
+        </p:txBody>
+      </p:sp>
+    </p:spTree>
+  </p:cSld>
+</p:notes>
+</file>
+
+<file path=ppt/notesSlides/notesSlide16.xml><?xml version="1.0" encoding="utf-8"?>
+<p:notes xmlns:a="http://schemas.openxmlformats.org/drawingml/2006/main" xmlns:r="http://schemas.openxmlformats.org/officeDocument/2006/relationships" xmlns:p="http://schemas.openxmlformats.org/presentationml/2006/main">
+  <p:cSld>
+    <p:spTree>
+      <p:nvGrpSpPr>
+        <p:cNvPr id="1" name=""/>
+        <p:cNvGrpSpPr/>
+        <p:nvPr/>
+      </p:nvGrpSpPr>
+      <p:grpSpPr>
+        <a:xfrm>
+          <a:off x="0" y="0"/>
+          <a:ext cx="0" cy="0"/>
+          <a:chOff x="0" y="0"/>
+          <a:chExt cx="0" cy="0"/>
+        </a:xfrm>
+      </p:grpSpPr>
+      <p:sp>
+        <p:nvSpPr>
+          <p:cNvPr id="2" name="Slide Image Placeholder 1"/>
+          <p:cNvSpPr>
+            <a:spLocks noGrp="1" noRot="1" noChangeAspect="1"/>
+          </p:cNvSpPr>
+          <p:nvPr>
+            <p:ph type="sldImg"/>
+          </p:nvPr>
+        </p:nvSpPr>
+        <p:spPr/>
+      </p:sp>
+      <p:sp>
+        <p:nvSpPr>
+          <p:cNvPr id="3" name="Notes Placeholder 2"/>
+          <p:cNvSpPr>
+            <a:spLocks noGrp="1"/>
+          </p:cNvSpPr>
+          <p:nvPr>
+            <p:ph type="body" idx="1"/>
+          </p:nvPr>
+        </p:nvSpPr>
+        <p:spPr/>
+        <p:txBody>
+          <a:bodyPr/>
+          <a:lstStyle/>
+          <a:p>
+            <a:pPr lvl="0" indent="0" marL="0">
+              <a:buNone/>
+            </a:pPr>
+            <a:r>
+              <a:rPr/>
+              <a:t>Three commands to remember, and the difference between them is the whole point. </a:t>
+            </a:r>
+            <a:r>
+              <a:rPr>
+                <a:latin typeface="Courier"/>
+              </a:rPr>
+              <a:t>ruff format &lt;path&gt;</a:t>
+            </a:r>
+            <a:r>
+              <a:rPr/>
+              <a:t> rewrites the file in place and prints </a:t>
+            </a:r>
+            <a:r>
+              <a:rPr>
+                <a:latin typeface="Courier"/>
+              </a:rPr>
+              <a:t>1 file reformatted</a:t>
+            </a:r>
+            <a:r>
+              <a:rPr/>
+              <a:t>. A directory (</a:t>
+            </a:r>
+            <a:r>
+              <a:rPr>
+                <a:latin typeface="Courier"/>
+              </a:rPr>
+              <a:t>.</a:t>
+            </a:r>
+            <a:r>
+              <a:rPr/>
+              <a:t> is the current one) means every </a:t>
+            </a:r>
+            <a:r>
+              <a:rPr>
+                <a:latin typeface="Courier"/>
+              </a:rPr>
+              <a:t>.py</a:t>
+            </a:r>
+            <a:r>
+              <a:rPr/>
+              <a:t> file below it; files listed in </a:t>
+            </a:r>
+            <a:r>
+              <a:rPr>
+                <a:latin typeface="Courier"/>
+              </a:rPr>
+              <a:t>.gitignore</a:t>
+            </a:r>
+            <a:r>
+              <a:rPr/>
+              <a:t> are skipped, so </a:t>
+            </a:r>
+            <a:r>
+              <a:rPr>
+                <a:latin typeface="Courier"/>
+              </a:rPr>
+              <a:t>.venv/</a:t>
+            </a:r>
+            <a:r>
+              <a:rPr/>
+              <a:t> is not touched. </a:t>
+            </a:r>
+            <a:r>
+              <a:rPr>
+                <a:latin typeface="Courier"/>
+              </a:rPr>
+              <a:t>--check</a:t>
+            </a:r>
+            <a:r>
+              <a:rPr/>
+              <a:t> is the read-only version: it lists the files that </a:t>
+            </a:r>
+            <a:r>
+              <a:rPr i="1"/>
+              <a:t>would</a:t>
+            </a:r>
+            <a:r>
+              <a:rPr/>
+              <a:t> change and exits with a non-zero status if there are any. That is exactly what you put in a pull-request check or a git hook: it fails the build instead of silently editing the author’s code. </a:t>
+            </a:r>
+            <a:r>
+              <a:rPr>
+                <a:latin typeface="Courier"/>
+              </a:rPr>
+              <a:t>ruff check</a:t>
+            </a:r>
+            <a:r>
+              <a:rPr/>
+              <a:t> is the linter, a different command from </a:t>
+            </a:r>
+            <a:r>
+              <a:rPr>
+                <a:latin typeface="Courier"/>
+              </a:rPr>
+              <a:t>format</a:t>
+            </a:r>
+            <a:r>
+              <a:rPr/>
+              <a:t>; </a:t>
+            </a:r>
+            <a:r>
+              <a:rPr>
+                <a:latin typeface="Courier"/>
+              </a:rPr>
+              <a:t>--fix</a:t>
+            </a:r>
+            <a:r>
+              <a:rPr/>
+              <a:t> applies only the corrections ruff considers safe. Practical advice: run </a:t>
+            </a:r>
+            <a:r>
+              <a:rPr>
+                <a:latin typeface="Courier"/>
+              </a:rPr>
+              <a:t>ruff format .</a:t>
+            </a:r>
+            <a:r>
+              <a:rPr/>
+              <a:t> once at the start of a project, commit that as “format with ruff” on its own, and from then on every diff stays small. Doing it in the middle of a feature branch produces a 400-line commit that hides the one line that matters. Demonstrate live on </a:t>
+            </a:r>
+            <a:r>
+              <a:rPr>
+                <a:latin typeface="Courier"/>
+              </a:rPr>
+              <a:t>clean.py</a:t>
+            </a:r>
+            <a:r>
+              <a:rPr/>
+              <a:t> from the notebook: </a:t>
+            </a:r>
+            <a:r>
+              <a:rPr>
+                <a:latin typeface="Courier"/>
+              </a:rPr>
+              <a:t>ruff format --check clean.py</a:t>
+            </a:r>
+            <a:r>
+              <a:rPr/>
+              <a:t>, then </a:t>
+            </a:r>
+            <a:r>
+              <a:rPr>
+                <a:latin typeface="Courier"/>
+              </a:rPr>
+              <a:t>ruff format clean.py</a:t>
+            </a:r>
+            <a:r>
+              <a:rPr/>
+              <a:t>, then </a:t>
+            </a:r>
+            <a:r>
+              <a:rPr>
+                <a:latin typeface="Courier"/>
+              </a:rPr>
+              <a:t>git diff</a:t>
+            </a:r>
+            <a:r>
+              <a:rPr/>
+              <a:t>.</a:t>
+            </a:r>
+          </a:p>
+        </p:txBody>
+      </p:sp>
+      <p:sp>
+        <p:nvSpPr>
+          <p:cNvPr id="4" name="Slide Number Placeholder 3"/>
+          <p:cNvSpPr>
+            <a:spLocks noGrp="1"/>
+          </p:cNvSpPr>
+          <p:nvPr>
+            <p:ph type="sldNum" sz="quarter" idx="10"/>
+          </p:nvPr>
+        </p:nvSpPr>
+        <p:spPr/>
+        <p:txBody>
+          <a:bodyPr/>
+          <a:lstStyle/>
+          <a:p>
+            <a:fld id="{18BDFEC3-8487-43E8-A154-7C12CBC1FFF2}" type="slidenum">
+              <a:rPr lang="en-US"/>
+              <a:t>21</a:t>
+            </a:fld>
+            <a:endParaRPr lang="en-US"/>
+          </a:p>
+        </p:txBody>
+      </p:sp>
+    </p:spTree>
+  </p:cSld>
+</p:notes>
+</file>
+
+<file path=ppt/notesSlides/notesSlide17.xml><?xml version="1.0" encoding="utf-8"?>
+<p:notes xmlns:a="http://schemas.openxmlformats.org/drawingml/2006/main" xmlns:r="http://schemas.openxmlformats.org/officeDocument/2006/relationships" xmlns:p="http://schemas.openxmlformats.org/presentationml/2006/main">
+  <p:cSld>
+    <p:spTree>
+      <p:nvGrpSpPr>
+        <p:cNvPr id="1" name=""/>
+        <p:cNvGrpSpPr/>
+        <p:nvPr/>
+      </p:nvGrpSpPr>
+      <p:grpSpPr>
+        <a:xfrm>
+          <a:off x="0" y="0"/>
+          <a:ext cx="0" cy="0"/>
+          <a:chOff x="0" y="0"/>
+          <a:chExt cx="0" cy="0"/>
+        </a:xfrm>
+      </p:grpSpPr>
+      <p:sp>
+        <p:nvSpPr>
+          <p:cNvPr id="2" name="Slide Image Placeholder 1"/>
+          <p:cNvSpPr>
+            <a:spLocks noGrp="1" noRot="1" noChangeAspect="1"/>
+          </p:cNvSpPr>
+          <p:nvPr>
+            <p:ph type="sldImg"/>
+          </p:nvPr>
+        </p:nvSpPr>
+        <p:spPr/>
+      </p:sp>
+      <p:sp>
+        <p:nvSpPr>
+          <p:cNvPr id="3" name="Notes Placeholder 2"/>
+          <p:cNvSpPr>
+            <a:spLocks noGrp="1"/>
+          </p:cNvSpPr>
+          <p:nvPr>
+            <p:ph type="body" idx="1"/>
+          </p:nvPr>
+        </p:nvSpPr>
+        <p:spPr/>
+        <p:txBody>
+          <a:bodyPr/>
+          <a:lstStyle/>
+          <a:p>
+            <a:pPr lvl="0" indent="0" marL="0">
+              <a:buNone/>
+            </a:pPr>
+            <a:r>
+              <a:rPr/>
+              <a:t>Two real findings on seven lines, and they are not equally safe to repair. </a:t>
+            </a:r>
+            <a:r>
+              <a:rPr>
+                <a:latin typeface="Courier"/>
+              </a:rPr>
+              <a:t>F401 os imported but unused</a:t>
+            </a:r>
+            <a:r>
+              <a:rPr/>
+              <a:t>: the import does nothing, so deleting the line cannot change the result. Ruff marks that fix </a:t>
+            </a:r>
+            <a:r>
+              <a:rPr b="1"/>
+              <a:t>safe</a:t>
+            </a:r>
+            <a:r>
+              <a:rPr/>
+              <a:t>, and </a:t>
+            </a:r>
+            <a:r>
+              <a:rPr>
+                <a:latin typeface="Courier"/>
+              </a:rPr>
+              <a:t>ruff check --fix vitals.py</a:t>
+            </a:r>
+            <a:r>
+              <a:rPr/>
+              <a:t> removes it for you (and sorts the remaining imports, </a:t>
+            </a:r>
+            <a:r>
+              <a:rPr>
+                <a:latin typeface="Courier"/>
+              </a:rPr>
+              <a:t>I001</a:t>
+            </a:r>
+            <a:r>
+              <a:rPr/>
+              <a:t>). </a:t>
+            </a:r>
+            <a:r>
+              <a:rPr>
+                <a:latin typeface="Courier"/>
+              </a:rPr>
+              <a:t>F841 local variable n is assigned to but never used</a:t>
+            </a:r>
+            <a:r>
+              <a:rPr/>
+              <a:t>: here ruff’s fix is to drop the </a:t>
+            </a:r>
+            <a:r>
+              <a:rPr>
+                <a:latin typeface="Courier"/>
+              </a:rPr>
+              <a:t>n =</a:t>
+            </a:r>
+            <a:r>
+              <a:rPr/>
+              <a:t> and keep the call, </a:t>
+            </a:r>
+            <a:r>
+              <a:rPr>
+                <a:latin typeface="Courier"/>
+              </a:rPr>
+              <a:t>len(df)</a:t>
+            </a:r>
+            <a:r>
+              <a:rPr/>
+              <a:t>. It marks it </a:t>
+            </a:r>
+            <a:r>
+              <a:rPr b="1"/>
+              <a:t>unsafe</a:t>
+            </a:r>
+            <a:r>
+              <a:rPr/>
+              <a:t>, because the right-hand side might be doing something: </a:t>
+            </a:r>
+            <a:r>
+              <a:rPr>
+                <a:latin typeface="Courier"/>
+              </a:rPr>
+              <a:t>n = log_access(patient_id)</a:t>
+            </a:r>
+            <a:r>
+              <a:rPr/>
+              <a:t> would still be called, but </a:t>
+            </a:r>
+            <a:r>
+              <a:rPr>
+                <a:latin typeface="Courier"/>
+              </a:rPr>
+              <a:t>n = df.pop("hr")</a:t>
+            </a:r>
+            <a:r>
+              <a:rPr/>
+              <a:t> changes </a:t>
+            </a:r>
+            <a:r>
+              <a:rPr>
+                <a:latin typeface="Courier"/>
+              </a:rPr>
+              <a:t>df</a:t>
+            </a:r>
+            <a:r>
+              <a:rPr/>
+              <a:t>, and deleting the whole line would change the result. Ruff refuses to guess. So </a:t>
+            </a:r>
+            <a:r>
+              <a:rPr>
+                <a:latin typeface="Courier"/>
+              </a:rPr>
+              <a:t>--fix</a:t>
+            </a:r>
+            <a:r>
+              <a:rPr/>
+              <a:t> leaves it alone and tells you a </a:t>
+            </a:r>
+            <a:r>
+              <a:rPr>
+                <a:latin typeface="Courier"/>
+              </a:rPr>
+              <a:t>--unsafe-fixes</a:t>
+            </a:r>
+            <a:r>
+              <a:rPr/>
+              <a:t> is available; you only get it with </a:t>
+            </a:r>
+            <a:r>
+              <a:rPr>
+                <a:latin typeface="Courier"/>
+              </a:rPr>
+              <a:t>ruff check --fix --unsafe-fixes .</a:t>
+            </a:r>
+            <a:r>
+              <a:rPr/>
+              <a:t>, and then you read the diff before committing. The rule for the room: </a:t>
+            </a:r>
+            <a:r>
+              <a:rPr>
+                <a:latin typeface="Courier"/>
+              </a:rPr>
+              <a:t>--fix</a:t>
+            </a:r>
+            <a:r>
+              <a:rPr/>
+              <a:t> can run unattended, even in a hook. </a:t>
+            </a:r>
+            <a:r>
+              <a:rPr>
+                <a:latin typeface="Courier"/>
+              </a:rPr>
+              <a:t>--unsafe-fixes</a:t>
+            </a:r>
+            <a:r>
+              <a:rPr/>
+              <a:t> is something you run yourself, on a clean working tree, and check with </a:t>
+            </a:r>
+            <a:r>
+              <a:rPr>
+                <a:latin typeface="Courier"/>
+              </a:rPr>
+              <a:t>git diff</a:t>
+            </a:r>
+            <a:r>
+              <a:rPr/>
+              <a:t>. Also note F841 is often a real bug, not untidiness: the variable you computed and forgot to return, or a typo where you assigned </a:t>
+            </a:r>
+            <a:r>
+              <a:rPr>
+                <a:latin typeface="Courier"/>
+              </a:rPr>
+              <a:t>mena</a:t>
+            </a:r>
+            <a:r>
+              <a:rPr/>
+              <a:t> and used </a:t>
+            </a:r>
+            <a:r>
+              <a:rPr>
+                <a:latin typeface="Courier"/>
+              </a:rPr>
+              <a:t>mean</a:t>
+            </a:r>
+            <a:r>
+              <a:rPr/>
+              <a:t>. Do not auto-delete the evidence, read it.</a:t>
+            </a:r>
+          </a:p>
+        </p:txBody>
+      </p:sp>
+      <p:sp>
+        <p:nvSpPr>
+          <p:cNvPr id="4" name="Slide Number Placeholder 3"/>
+          <p:cNvSpPr>
+            <a:spLocks noGrp="1"/>
+          </p:cNvSpPr>
+          <p:nvPr>
+            <p:ph type="sldNum" sz="quarter" idx="10"/>
+          </p:nvPr>
+        </p:nvSpPr>
+        <p:spPr/>
+        <p:txBody>
+          <a:bodyPr/>
+          <a:lstStyle/>
+          <a:p>
+            <a:fld id="{18BDFEC3-8487-43E8-A154-7C12CBC1FFF2}" type="slidenum">
+              <a:rPr lang="en-US"/>
+              <a:t>22</a:t>
             </a:fld>
             <a:endParaRPr lang="en-US"/>
           </a:p>
@@ -5072,7 +5740,7 @@
             </a:pPr>
             <a:r>
               <a:rPr/>
-              <a:t>Session 2</a:t>
+              <a:t>Session 3</a:t>
             </a:r>
             <a:br/>
             <a:r>
@@ -5803,118 +6471,37 @@
             </a:pPr>
             <a:r>
               <a:rPr>
-                <a:solidFill>
-                  <a:srgbClr val="06287E"/>
-                </a:solidFill>
-                <a:latin typeface="Courier"/>
-              </a:rPr>
-              <a:t>git</a:t>
-            </a:r>
-            <a:r>
-              <a:rPr>
-                <a:latin typeface="Courier"/>
-              </a:rPr>
-              <a:t> init              </a:t>
-            </a:r>
-            <a:r>
-              <a:rPr i="1">
-                <a:solidFill>
-                  <a:srgbClr val="60A0B0"/>
-                </a:solidFill>
-                <a:latin typeface="Courier"/>
-              </a:rPr>
-              <a:t># once per project</a:t>
+                <a:latin typeface="Courier"/>
+              </a:rPr>
+              <a:t>$ git init</a:t>
             </a:r>
             <a:br/>
             <a:r>
               <a:rPr>
-                <a:solidFill>
-                  <a:srgbClr val="06287E"/>
-                </a:solidFill>
-                <a:latin typeface="Courier"/>
-              </a:rPr>
-              <a:t>git</a:t>
-            </a:r>
-            <a:r>
-              <a:rPr>
-                <a:latin typeface="Courier"/>
-              </a:rPr>
-              <a:t> status            </a:t>
-            </a:r>
-            <a:r>
-              <a:rPr i="1">
-                <a:solidFill>
-                  <a:srgbClr val="60A0B0"/>
-                </a:solidFill>
-                <a:latin typeface="Courier"/>
-              </a:rPr>
-              <a:t># what changed?</a:t>
+                <a:latin typeface="Courier"/>
+              </a:rPr>
+              <a:t>$ git status</a:t>
             </a:r>
             <a:br/>
             <a:r>
               <a:rPr>
-                <a:solidFill>
-                  <a:srgbClr val="06287E"/>
-                </a:solidFill>
-                <a:latin typeface="Courier"/>
-              </a:rPr>
-              <a:t>git</a:t>
-            </a:r>
-            <a:r>
-              <a:rPr>
-                <a:latin typeface="Courier"/>
-              </a:rPr>
-              <a:t> diff              </a:t>
-            </a:r>
-            <a:r>
-              <a:rPr i="1">
-                <a:solidFill>
-                  <a:srgbClr val="60A0B0"/>
-                </a:solidFill>
-                <a:latin typeface="Courier"/>
-              </a:rPr>
-              <a:t># show the changes</a:t>
+                <a:latin typeface="Courier"/>
+              </a:rPr>
+              <a:t>$ git diff</a:t>
             </a:r>
             <a:br/>
             <a:r>
               <a:rPr>
-                <a:solidFill>
-                  <a:srgbClr val="06287E"/>
-                </a:solidFill>
-                <a:latin typeface="Courier"/>
-              </a:rPr>
-              <a:t>git</a:t>
-            </a:r>
-            <a:r>
-              <a:rPr>
-                <a:latin typeface="Courier"/>
-              </a:rPr>
-              <a:t> add clean.py      </a:t>
-            </a:r>
-            <a:r>
-              <a:rPr i="1">
-                <a:solidFill>
-                  <a:srgbClr val="60A0B0"/>
-                </a:solidFill>
-                <a:latin typeface="Courier"/>
-              </a:rPr>
-              <a:t># stage a file</a:t>
+                <a:latin typeface="Courier"/>
+              </a:rPr>
+              <a:t>$ git add clean.py</a:t>
             </a:r>
             <a:br/>
             <a:r>
               <a:rPr>
-                <a:solidFill>
-                  <a:srgbClr val="06287E"/>
-                </a:solidFill>
-                <a:latin typeface="Courier"/>
-              </a:rPr>
-              <a:t>git</a:t>
-            </a:r>
-            <a:r>
-              <a:rPr>
-                <a:latin typeface="Courier"/>
-              </a:rPr>
-              <a:t> commit </a:t>
+                <a:latin typeface="Courier"/>
+              </a:rPr>
+              <a:t>$ git commit </a:t>
             </a:r>
             <a:r>
               <a:rPr>
@@ -5943,42 +6530,9 @@
             <a:br/>
             <a:r>
               <a:rPr>
-                <a:solidFill>
-                  <a:srgbClr val="06287E"/>
-                </a:solidFill>
-                <a:latin typeface="Courier"/>
-              </a:rPr>
-              <a:t>git</a:t>
-            </a:r>
-            <a:r>
-              <a:rPr>
-                <a:latin typeface="Courier"/>
-              </a:rPr>
-              <a:t> log </a:t>
-            </a:r>
-            <a:r>
-              <a:rPr>
-                <a:solidFill>
-                  <a:srgbClr val="7D9029"/>
-                </a:solidFill>
-                <a:latin typeface="Courier"/>
-              </a:rPr>
-              <a:t>--oneline</a:t>
-            </a:r>
-            <a:r>
-              <a:rPr>
-                <a:latin typeface="Courier"/>
-              </a:rPr>
-              <a:t>     </a:t>
-            </a:r>
-            <a:r>
-              <a:rPr i="1">
-                <a:solidFill>
-                  <a:srgbClr val="60A0B0"/>
-                </a:solidFill>
-                <a:latin typeface="Courier"/>
-              </a:rPr>
-              <a:t># the history</a:t>
+                <a:latin typeface="Courier"/>
+              </a:rPr>
+              <a:t>$ git log</a:t>
             </a:r>
           </a:p>
         </p:txBody>
@@ -6212,35 +6766,18 @@
             </a:pPr>
             <a:r>
               <a:rPr>
-                <a:solidFill>
-                  <a:srgbClr val="06287E"/>
-                </a:solidFill>
-                <a:latin typeface="Courier"/>
-              </a:rPr>
-              <a:t>git</a:t>
-            </a:r>
-            <a:r>
-              <a:rPr>
-                <a:latin typeface="Courier"/>
-              </a:rPr>
-              <a:t> clone https://github.com/org/repo</a:t>
+                <a:latin typeface="Courier"/>
+              </a:rPr>
+              <a:t>$ git clone https://github.com/org/repo</a:t>
             </a:r>
             <a:br/>
             <a:r>
               <a:rPr>
-                <a:solidFill>
-                  <a:srgbClr val="008000"/>
-                </a:solidFill>
-                <a:latin typeface="Courier"/>
-              </a:rPr>
-              <a:t>cd</a:t>
-            </a:r>
-            <a:r>
-              <a:rPr>
-                <a:latin typeface="Courier"/>
-              </a:rPr>
-              <a:t> repo</a:t>
-            </a:r>
+                <a:latin typeface="Courier"/>
+              </a:rPr>
+              <a:t>$ cd repo</a:t>
+            </a:r>
+            <a:br/>
             <a:br/>
             <a:r>
               <a:rPr i="1">
@@ -6252,21 +6789,7 @@
               <a:t># ... edit, add, commit ...</a:t>
             </a:r>
             <a:br/>
-            <a:r>
-              <a:rPr>
-                <a:solidFill>
-                  <a:srgbClr val="06287E"/>
-                </a:solidFill>
-                <a:latin typeface="Courier"/>
-              </a:rPr>
-              <a:t>git</a:t>
-            </a:r>
-            <a:r>
-              <a:rPr>
-                <a:latin typeface="Courier"/>
-              </a:rPr>
-              <a:t> pull            </a:t>
-            </a:r>
+            <a:br/>
             <a:r>
               <a:rPr i="1">
                 <a:solidFill>
@@ -6279,19 +6802,11 @@
             <a:br/>
             <a:r>
               <a:rPr>
-                <a:solidFill>
-                  <a:srgbClr val="06287E"/>
-                </a:solidFill>
-                <a:latin typeface="Courier"/>
-              </a:rPr>
-              <a:t>git</a:t>
-            </a:r>
-            <a:r>
-              <a:rPr>
-                <a:latin typeface="Courier"/>
-              </a:rPr>
-              <a:t> push            </a:t>
-            </a:r>
+                <a:latin typeface="Courier"/>
+              </a:rPr>
+              <a:t>$ git pull</a:t>
+            </a:r>
+            <a:br/>
             <a:r>
               <a:rPr i="1">
                 <a:solidFill>
@@ -6300,6 +6815,13 @@
                 <a:latin typeface="Courier"/>
               </a:rPr>
               <a:t># publish yours</a:t>
+            </a:r>
+            <a:br/>
+            <a:r>
+              <a:rPr>
+                <a:latin typeface="Courier"/>
+              </a:rPr>
+              <a:t>$ git push</a:t>
             </a:r>
           </a:p>
         </p:txBody>
@@ -6452,6 +6974,60 @@
 </p:sld>
 </file>
 
+<file path=ppt/slides/slide19.xml><?xml version="1.0" encoding="utf-8"?>
+<p:sld xmlns:a="http://schemas.openxmlformats.org/drawingml/2006/main" xmlns:r="http://schemas.openxmlformats.org/officeDocument/2006/relationships" xmlns:p="http://schemas.openxmlformats.org/presentationml/2006/main">
+  <p:cSld>
+    <p:spTree>
+      <p:nvGrpSpPr>
+        <p:cNvPr id="1" name=""/>
+        <p:cNvGrpSpPr/>
+        <p:nvPr/>
+      </p:nvGrpSpPr>
+      <p:grpSpPr>
+        <a:xfrm>
+          <a:off x="0" y="0"/>
+          <a:ext cx="0" cy="0"/>
+          <a:chOff x="0" y="0"/>
+          <a:chExt cx="0" cy="0"/>
+        </a:xfrm>
+      </p:grpSpPr>
+      <p:sp>
+        <p:nvSpPr>
+          <p:cNvPr id="2" name="Title 1"/>
+          <p:cNvSpPr>
+            <a:spLocks noGrp="1"/>
+          </p:cNvSpPr>
+          <p:nvPr>
+            <p:ph type="title"/>
+          </p:nvPr>
+        </p:nvSpPr>
+        <p:spPr>
+          <a:xfrm>
+            <a:off x="722313" y="3305176"/>
+            <a:ext cx="7772400" cy="1021556"/>
+          </a:xfrm>
+        </p:spPr>
+        <p:txBody>
+          <a:bodyPr>
+            <a:normAutofit/>
+          </a:bodyPr>
+          <a:lstStyle/>
+          <a:p>
+            <a:pPr lvl="0" indent="0" marL="0">
+              <a:buNone/>
+            </a:pPr>
+            <a:r>
+              <a:rPr/>
+              <a:t>4. Keeping the code readable: ruff</a:t>
+            </a:r>
+          </a:p>
+        </p:txBody>
+      </p:sp>
+    </p:spTree>
+  </p:cSld>
+</p:sld>
+</file>
+
 <file path=ppt/slides/slide2.xml><?xml version="1.0" encoding="utf-8"?>
 <p:sld xmlns:a="http://schemas.openxmlformats.org/drawingml/2006/main" xmlns:r="http://schemas.openxmlformats.org/officeDocument/2006/relationships" xmlns:p="http://schemas.openxmlformats.org/presentationml/2006/main">
   <p:cSld>
@@ -6497,6 +7073,656 @@
             <a:r>
               <a:rPr/>
               <a:t>1. Why using a terminal?</a:t>
+            </a:r>
+          </a:p>
+        </p:txBody>
+      </p:sp>
+    </p:spTree>
+  </p:cSld>
+</p:sld>
+</file>
+
+<file path=ppt/slides/slide20.xml><?xml version="1.0" encoding="utf-8"?>
+<p:sld xmlns:a="http://schemas.openxmlformats.org/drawingml/2006/main" xmlns:r="http://schemas.openxmlformats.org/officeDocument/2006/relationships" xmlns:p="http://schemas.openxmlformats.org/presentationml/2006/main">
+  <p:cSld>
+    <p:spTree>
+      <p:nvGrpSpPr>
+        <p:cNvPr id="1" name=""/>
+        <p:cNvGrpSpPr/>
+        <p:nvPr/>
+      </p:nvGrpSpPr>
+      <p:grpSpPr>
+        <a:xfrm>
+          <a:off x="0" y="0"/>
+          <a:ext cx="0" cy="0"/>
+          <a:chOff x="0" y="0"/>
+          <a:chExt cx="0" cy="0"/>
+        </a:xfrm>
+      </p:grpSpPr>
+      <p:sp>
+        <p:nvSpPr>
+          <p:cNvPr id="2" name="Title 1"/>
+          <p:cNvSpPr>
+            <a:spLocks noGrp="1"/>
+          </p:cNvSpPr>
+          <p:nvPr>
+            <p:ph type="title"/>
+          </p:nvPr>
+        </p:nvSpPr>
+        <p:spPr/>
+        <p:txBody>
+          <a:bodyPr>
+            <a:normAutofit/>
+          </a:bodyPr>
+          <a:lstStyle/>
+          <a:p>
+            <a:pPr lvl="0" indent="0" marL="0">
+              <a:buNone/>
+            </a:pPr>
+            <a:r>
+              <a:rPr/>
+              <a:t>One style, decided by a tool</a:t>
+            </a:r>
+          </a:p>
+        </p:txBody>
+      </p:sp>
+      <p:sp>
+        <p:nvSpPr>
+          <p:cNvPr id="3" name="Content Placeholder 2"/>
+          <p:cNvSpPr>
+            <a:spLocks noGrp="1"/>
+          </p:cNvSpPr>
+          <p:nvPr>
+            <p:ph idx="1"/>
+          </p:nvPr>
+        </p:nvSpPr>
+        <p:spPr/>
+        <p:txBody>
+          <a:bodyPr>
+            <a:normAutofit/>
+          </a:bodyPr>
+          <a:lstStyle/>
+          <a:p>
+            <a:pPr lvl="0" indent="0">
+              <a:buNone/>
+            </a:pPr>
+            <a:r>
+              <a:rPr>
+                <a:latin typeface="Courier"/>
+              </a:rPr>
+              <a:t>$ uv venv</a:t>
+            </a:r>
+            <a:br/>
+            <a:r>
+              <a:rPr i="1">
+                <a:solidFill>
+                  <a:srgbClr val="60A0B0"/>
+                </a:solidFill>
+                <a:latin typeface="Courier"/>
+              </a:rPr>
+              <a:t># create .venv</a:t>
+            </a:r>
+            <a:br/>
+            <a:r>
+              <a:rPr>
+                <a:latin typeface="Courier"/>
+              </a:rPr>
+              <a:t>$ source .venv/bin/activate </a:t>
+            </a:r>
+            <a:r>
+              <a:rPr i="1">
+                <a:solidFill>
+                  <a:srgbClr val="60A0B0"/>
+                </a:solidFill>
+                <a:latin typeface="Courier"/>
+              </a:rPr>
+              <a:t># unix</a:t>
+            </a:r>
+            <a:br/>
+            <a:r>
+              <a:rPr>
+                <a:solidFill>
+                  <a:srgbClr val="666666"/>
+                </a:solidFill>
+                <a:latin typeface="Courier"/>
+              </a:rPr>
+              <a:t>&gt;</a:t>
+            </a:r>
+            <a:r>
+              <a:rPr>
+                <a:latin typeface="Courier"/>
+              </a:rPr>
+              <a:t> .venv\Scripts\activate </a:t>
+            </a:r>
+            <a:r>
+              <a:rPr i="1">
+                <a:solidFill>
+                  <a:srgbClr val="60A0B0"/>
+                </a:solidFill>
+                <a:latin typeface="Courier"/>
+              </a:rPr>
+              <a:t># windows</a:t>
+            </a:r>
+            <a:br/>
+            <a:br/>
+            <a:r>
+              <a:rPr>
+                <a:latin typeface="Courier"/>
+              </a:rPr>
+              <a:t>$ uv pip install ruff</a:t>
+            </a:r>
+            <a:br/>
+            <a:r>
+              <a:rPr i="1">
+                <a:solidFill>
+                  <a:srgbClr val="60A0B0"/>
+                </a:solidFill>
+                <a:latin typeface="Courier"/>
+              </a:rPr>
+              <a:t># or: uv add --dev ruff</a:t>
+            </a:r>
+            <a:br/>
+            <a:br/>
+            <a:r>
+              <a:rPr>
+                <a:latin typeface="Courier"/>
+              </a:rPr>
+              <a:t>$ ruff </a:t>
+            </a:r>
+            <a:r>
+              <a:rPr>
+                <a:solidFill>
+                  <a:srgbClr val="7D9029"/>
+                </a:solidFill>
+                <a:latin typeface="Courier"/>
+              </a:rPr>
+              <a:t>--version</a:t>
+            </a:r>
+          </a:p>
+        </p:txBody>
+      </p:sp>
+    </p:spTree>
+  </p:cSld>
+</p:sld>
+</file>
+
+<file path=ppt/slides/slide21.xml><?xml version="1.0" encoding="utf-8"?>
+<p:sld xmlns:a="http://schemas.openxmlformats.org/drawingml/2006/main" xmlns:r="http://schemas.openxmlformats.org/officeDocument/2006/relationships" xmlns:p="http://schemas.openxmlformats.org/presentationml/2006/main">
+  <p:cSld>
+    <p:spTree>
+      <p:nvGrpSpPr>
+        <p:cNvPr id="1" name=""/>
+        <p:cNvGrpSpPr/>
+        <p:nvPr/>
+      </p:nvGrpSpPr>
+      <p:grpSpPr>
+        <a:xfrm>
+          <a:off x="0" y="0"/>
+          <a:ext cx="0" cy="0"/>
+          <a:chOff x="0" y="0"/>
+          <a:chExt cx="0" cy="0"/>
+        </a:xfrm>
+      </p:grpSpPr>
+      <p:sp>
+        <p:nvSpPr>
+          <p:cNvPr id="2" name="Title 1"/>
+          <p:cNvSpPr>
+            <a:spLocks noGrp="1"/>
+          </p:cNvSpPr>
+          <p:nvPr>
+            <p:ph type="title"/>
+          </p:nvPr>
+        </p:nvSpPr>
+        <p:spPr/>
+        <p:txBody>
+          <a:bodyPr>
+            <a:normAutofit/>
+          </a:bodyPr>
+          <a:lstStyle/>
+          <a:p>
+            <a:pPr lvl="0" indent="0" marL="0">
+              <a:buNone/>
+            </a:pPr>
+            <a:r>
+              <a:rPr/>
+              <a:t>Format, and check</a:t>
+            </a:r>
+          </a:p>
+        </p:txBody>
+      </p:sp>
+      <p:sp>
+        <p:nvSpPr>
+          <p:cNvPr id="3" name="Content Placeholder 2"/>
+          <p:cNvSpPr>
+            <a:spLocks noGrp="1"/>
+          </p:cNvSpPr>
+          <p:nvPr>
+            <p:ph idx="1"/>
+          </p:nvPr>
+        </p:nvSpPr>
+        <p:spPr/>
+        <p:txBody>
+          <a:bodyPr>
+            <a:normAutofit/>
+          </a:bodyPr>
+          <a:lstStyle/>
+          <a:p>
+            <a:pPr lvl="0" indent="0">
+              <a:buNone/>
+            </a:pPr>
+            <a:r>
+              <a:rPr i="1">
+                <a:solidFill>
+                  <a:srgbClr val="60A0B0"/>
+                </a:solidFill>
+                <a:latin typeface="Courier"/>
+              </a:rPr>
+              <a:t># format one file</a:t>
+            </a:r>
+            <a:br/>
+            <a:r>
+              <a:rPr>
+                <a:latin typeface="Courier"/>
+              </a:rPr>
+              <a:t>$ ruff format clean.py</a:t>
+            </a:r>
+            <a:br/>
+            <a:r>
+              <a:rPr i="1">
+                <a:solidFill>
+                  <a:srgbClr val="60A0B0"/>
+                </a:solidFill>
+                <a:latin typeface="Courier"/>
+              </a:rPr>
+              <a:t># format everything, recursively</a:t>
+            </a:r>
+            <a:br/>
+            <a:r>
+              <a:rPr>
+                <a:latin typeface="Courier"/>
+              </a:rPr>
+              <a:t>$ ruff format .</a:t>
+            </a:r>
+            <a:br/>
+            <a:br/>
+            <a:r>
+              <a:rPr i="1">
+                <a:solidFill>
+                  <a:srgbClr val="60A0B0"/>
+                </a:solidFill>
+                <a:latin typeface="Courier"/>
+              </a:rPr>
+              <a:t># report, but change nothing</a:t>
+            </a:r>
+            <a:br/>
+            <a:r>
+              <a:rPr>
+                <a:latin typeface="Courier"/>
+              </a:rPr>
+              <a:t>$ ruff format </a:t>
+            </a:r>
+            <a:r>
+              <a:rPr>
+                <a:solidFill>
+                  <a:srgbClr val="7D9029"/>
+                </a:solidFill>
+                <a:latin typeface="Courier"/>
+              </a:rPr>
+              <a:t>--check</a:t>
+            </a:r>
+            <a:r>
+              <a:rPr>
+                <a:latin typeface="Courier"/>
+              </a:rPr>
+              <a:t> .</a:t>
+            </a:r>
+            <a:br/>
+            <a:r>
+              <a:rPr i="1">
+                <a:solidFill>
+                  <a:srgbClr val="60A0B0"/>
+                </a:solidFill>
+                <a:latin typeface="Courier"/>
+              </a:rPr>
+              <a:t># lint: find likely mistakes</a:t>
+            </a:r>
+            <a:br/>
+            <a:r>
+              <a:rPr>
+                <a:latin typeface="Courier"/>
+              </a:rPr>
+              <a:t>$ ruff check .</a:t>
+            </a:r>
+            <a:br/>
+            <a:r>
+              <a:rPr i="1">
+                <a:solidFill>
+                  <a:srgbClr val="60A0B0"/>
+                </a:solidFill>
+                <a:latin typeface="Courier"/>
+              </a:rPr>
+              <a:t># lint, and fix what is safe</a:t>
+            </a:r>
+            <a:br/>
+            <a:r>
+              <a:rPr>
+                <a:latin typeface="Courier"/>
+              </a:rPr>
+              <a:t>$ ruff check </a:t>
+            </a:r>
+            <a:r>
+              <a:rPr>
+                <a:solidFill>
+                  <a:srgbClr val="7D9029"/>
+                </a:solidFill>
+                <a:latin typeface="Courier"/>
+              </a:rPr>
+              <a:t>--fix</a:t>
+            </a:r>
+            <a:r>
+              <a:rPr>
+                <a:latin typeface="Courier"/>
+              </a:rPr>
+              <a:t> .</a:t>
+            </a:r>
+          </a:p>
+        </p:txBody>
+      </p:sp>
+    </p:spTree>
+  </p:cSld>
+</p:sld>
+</file>
+
+<file path=ppt/slides/slide22.xml><?xml version="1.0" encoding="utf-8"?>
+<p:sld xmlns:a="http://schemas.openxmlformats.org/drawingml/2006/main" xmlns:r="http://schemas.openxmlformats.org/officeDocument/2006/relationships" xmlns:p="http://schemas.openxmlformats.org/presentationml/2006/main">
+  <p:cSld>
+    <p:spTree>
+      <p:nvGrpSpPr>
+        <p:cNvPr id="1" name=""/>
+        <p:cNvGrpSpPr/>
+        <p:nvPr/>
+      </p:nvGrpSpPr>
+      <p:grpSpPr>
+        <a:xfrm>
+          <a:off x="0" y="0"/>
+          <a:ext cx="0" cy="0"/>
+          <a:chOff x="0" y="0"/>
+          <a:chExt cx="0" cy="0"/>
+        </a:xfrm>
+      </p:grpSpPr>
+      <p:sp>
+        <p:nvSpPr>
+          <p:cNvPr id="2" name="Title 1"/>
+          <p:cNvSpPr>
+            <a:spLocks noGrp="1"/>
+          </p:cNvSpPr>
+          <p:nvPr>
+            <p:ph type="title"/>
+          </p:nvPr>
+        </p:nvSpPr>
+        <p:spPr/>
+        <p:txBody>
+          <a:bodyPr>
+            <a:normAutofit/>
+          </a:bodyPr>
+          <a:lstStyle/>
+          <a:p>
+            <a:pPr lvl="0" indent="0" marL="0">
+              <a:buNone/>
+            </a:pPr>
+            <a:r>
+              <a:rPr/>
+              <a:t>A lint check, safe and unsafe</a:t>
+            </a:r>
+          </a:p>
+        </p:txBody>
+      </p:sp>
+      <p:sp>
+        <p:nvSpPr>
+          <p:cNvPr id="3" name="Content Placeholder 2"/>
+          <p:cNvSpPr>
+            <a:spLocks noGrp="1"/>
+          </p:cNvSpPr>
+          <p:nvPr>
+            <p:ph idx="1"/>
+          </p:nvPr>
+        </p:nvSpPr>
+        <p:spPr/>
+        <p:txBody>
+          <a:bodyPr>
+            <a:normAutofit/>
+          </a:bodyPr>
+          <a:lstStyle/>
+          <a:p>
+            <a:pPr lvl="0" indent="0">
+              <a:buNone/>
+            </a:pPr>
+            <a:r>
+              <a:rPr b="1">
+                <a:solidFill>
+                  <a:srgbClr val="008000"/>
+                </a:solidFill>
+                <a:latin typeface="Courier"/>
+              </a:rPr>
+              <a:t>import</a:t>
+            </a:r>
+            <a:r>
+              <a:rPr>
+                <a:latin typeface="Courier"/>
+              </a:rPr>
+              <a:t> os</a:t>
+            </a:r>
+            <a:br/>
+            <a:r>
+              <a:rPr i="1">
+                <a:solidFill>
+                  <a:srgbClr val="60A0B0"/>
+                </a:solidFill>
+                <a:latin typeface="Courier"/>
+              </a:rPr>
+              <a:t># F401 unused import   -&gt; safe fix</a:t>
+            </a:r>
+            <a:br/>
+            <a:r>
+              <a:rPr b="1">
+                <a:solidFill>
+                  <a:srgbClr val="008000"/>
+                </a:solidFill>
+                <a:latin typeface="Courier"/>
+              </a:rPr>
+              <a:t>import</a:t>
+            </a:r>
+            <a:r>
+              <a:rPr>
+                <a:latin typeface="Courier"/>
+              </a:rPr>
+              <a:t> pandas </a:t>
+            </a:r>
+            <a:r>
+              <a:rPr b="1">
+                <a:solidFill>
+                  <a:srgbClr val="008000"/>
+                </a:solidFill>
+                <a:latin typeface="Courier"/>
+              </a:rPr>
+              <a:t>as</a:t>
+            </a:r>
+            <a:r>
+              <a:rPr>
+                <a:latin typeface="Courier"/>
+              </a:rPr>
+              <a:t> pd</a:t>
+            </a:r>
+            <a:br/>
+            <a:br/>
+            <a:r>
+              <a:rPr b="1">
+                <a:solidFill>
+                  <a:srgbClr val="007020"/>
+                </a:solidFill>
+                <a:latin typeface="Courier"/>
+              </a:rPr>
+              <a:t>def</a:t>
+            </a:r>
+            <a:r>
+              <a:rPr>
+                <a:latin typeface="Courier"/>
+              </a:rPr>
+              <a:t> mean_hr(path):</a:t>
+            </a:r>
+            <a:br/>
+            <a:r>
+              <a:rPr>
+                <a:latin typeface="Courier"/>
+              </a:rPr>
+              <a:t>    df </a:t>
+            </a:r>
+            <a:r>
+              <a:rPr>
+                <a:solidFill>
+                  <a:srgbClr val="666666"/>
+                </a:solidFill>
+                <a:latin typeface="Courier"/>
+              </a:rPr>
+              <a:t>=</a:t>
+            </a:r>
+            <a:r>
+              <a:rPr>
+                <a:latin typeface="Courier"/>
+              </a:rPr>
+              <a:t> pd.read_csv(path)</a:t>
+            </a:r>
+            <a:br/>
+            <a:r>
+              <a:rPr>
+                <a:latin typeface="Courier"/>
+              </a:rPr>
+              <a:t>    n </a:t>
+            </a:r>
+            <a:r>
+              <a:rPr>
+                <a:solidFill>
+                  <a:srgbClr val="666666"/>
+                </a:solidFill>
+                <a:latin typeface="Courier"/>
+              </a:rPr>
+              <a:t>=</a:t>
+            </a:r>
+            <a:r>
+              <a:rPr>
+                <a:latin typeface="Courier"/>
+              </a:rPr>
+              <a:t> </a:t>
+            </a:r>
+            <a:r>
+              <a:rPr>
+                <a:solidFill>
+                  <a:srgbClr val="008000"/>
+                </a:solidFill>
+                <a:latin typeface="Courier"/>
+              </a:rPr>
+              <a:t>len</a:t>
+            </a:r>
+            <a:r>
+              <a:rPr>
+                <a:latin typeface="Courier"/>
+              </a:rPr>
+              <a:t>(df)</a:t>
+            </a:r>
+            <a:br/>
+            <a:r>
+              <a:rPr>
+                <a:latin typeface="Courier"/>
+              </a:rPr>
+              <a:t>    </a:t>
+            </a:r>
+            <a:r>
+              <a:rPr i="1">
+                <a:solidFill>
+                  <a:srgbClr val="60A0B0"/>
+                </a:solidFill>
+                <a:latin typeface="Courier"/>
+              </a:rPr>
+              <a:t># F841 unused variable -&gt; unsafe fix</a:t>
+            </a:r>
+            <a:br/>
+            <a:r>
+              <a:rPr>
+                <a:latin typeface="Courier"/>
+              </a:rPr>
+              <a:t>    </a:t>
+            </a:r>
+            <a:r>
+              <a:rPr b="1">
+                <a:solidFill>
+                  <a:srgbClr val="007020"/>
+                </a:solidFill>
+                <a:latin typeface="Courier"/>
+              </a:rPr>
+              <a:t>return</a:t>
+            </a:r>
+            <a:r>
+              <a:rPr>
+                <a:latin typeface="Courier"/>
+              </a:rPr>
+              <a:t> df[</a:t>
+            </a:r>
+            <a:r>
+              <a:rPr>
+                <a:solidFill>
+                  <a:srgbClr val="4070A0"/>
+                </a:solidFill>
+                <a:latin typeface="Courier"/>
+              </a:rPr>
+              <a:t>"hr"</a:t>
+            </a:r>
+            <a:r>
+              <a:rPr>
+                <a:latin typeface="Courier"/>
+              </a:rPr>
+              <a:t>].mean()</a:t>
+            </a:r>
+          </a:p>
+          <a:p>
+            <a:pPr lvl="0" indent="0">
+              <a:buNone/>
+            </a:pPr>
+            <a:br/>
+            <a:r>
+              <a:rPr>
+                <a:latin typeface="Courier"/>
+              </a:rPr>
+              <a:t>$ ruff check vitals.py</a:t>
+            </a:r>
+            <a:br/>
+            <a:r>
+              <a:rPr i="1">
+                <a:solidFill>
+                  <a:srgbClr val="60A0B0"/>
+                </a:solidFill>
+                <a:latin typeface="Courier"/>
+              </a:rPr>
+              <a:t># Found 2 errors:</a:t>
+            </a:r>
+            <a:br/>
+            <a:r>
+              <a:rPr i="1">
+                <a:solidFill>
+                  <a:srgbClr val="60A0B0"/>
+                </a:solidFill>
+                <a:latin typeface="Courier"/>
+              </a:rPr>
+              <a:t># * 1 fixable with `--fix`</a:t>
+            </a:r>
+            <a:br/>
+            <a:r>
+              <a:rPr i="1">
+                <a:solidFill>
+                  <a:srgbClr val="60A0B0"/>
+                </a:solidFill>
+                <a:latin typeface="Courier"/>
+              </a:rPr>
+              <a:t># * 1 unsafe fix available with `--fix --unsafe-fixes`</a:t>
             </a:r>
           </a:p>
         </p:txBody>
@@ -6941,21 +8167,6 @@
               <a:buNone/>
             </a:pPr>
             <a:r>
-              <a:rPr>
-                <a:solidFill>
-                  <a:srgbClr val="008000"/>
-                </a:solidFill>
-                <a:latin typeface="Courier"/>
-              </a:rPr>
-              <a:t>pwd</a:t>
-            </a:r>
-            <a:r>
-              <a:rPr>
-                <a:latin typeface="Courier"/>
-              </a:rPr>
-              <a:t>                     </a:t>
-            </a:r>
-            <a:r>
               <a:rPr i="1">
                 <a:solidFill>
                   <a:srgbClr val="60A0B0"/>
@@ -6967,19 +8178,11 @@
             <a:br/>
             <a:r>
               <a:rPr>
-                <a:solidFill>
-                  <a:srgbClr val="008000"/>
-                </a:solidFill>
-                <a:latin typeface="Courier"/>
-              </a:rPr>
-              <a:t>cd</a:t>
-            </a:r>
-            <a:r>
-              <a:rPr>
-                <a:latin typeface="Courier"/>
-              </a:rPr>
-              <a:t> data/ecg             </a:t>
-            </a:r>
+                <a:latin typeface="Courier"/>
+              </a:rPr>
+              <a:t>$ pwd</a:t>
+            </a:r>
+            <a:br/>
             <a:r>
               <a:rPr i="1">
                 <a:solidFill>
@@ -6987,39 +8190,16 @@
                 </a:solidFill>
                 <a:latin typeface="Courier"/>
               </a:rPr>
-              <a:t># go there  (cd ..  goes up, cd  goes home)</a:t>
+              <a:t># go there  (cd .. to parent directory)</a:t>
             </a:r>
             <a:br/>
             <a:r>
               <a:rPr>
-                <a:solidFill>
-                  <a:srgbClr val="06287E"/>
-                </a:solidFill>
-                <a:latin typeface="Courier"/>
-              </a:rPr>
-              <a:t>ls</a:t>
-            </a:r>
-            <a:r>
-              <a:rPr>
-                <a:latin typeface="Courier"/>
-              </a:rPr>
-              <a:t> </a:t>
-            </a:r>
-            <a:r>
-              <a:rPr>
-                <a:solidFill>
-                  <a:srgbClr val="7D9029"/>
-                </a:solidFill>
-                <a:latin typeface="Courier"/>
-              </a:rPr>
-              <a:t>-lh</a:t>
-            </a:r>
-            <a:r>
-              <a:rPr>
-                <a:latin typeface="Courier"/>
-              </a:rPr>
-              <a:t>                  </a:t>
-            </a:r>
+                <a:latin typeface="Courier"/>
+              </a:rPr>
+              <a:t>$ cd data/ecg</a:t>
+            </a:r>
+            <a:br/>
             <a:r>
               <a:rPr i="1">
                 <a:solidFill>
@@ -7027,23 +8207,14 @@
                 </a:solidFill>
                 <a:latin typeface="Courier"/>
               </a:rPr>
-              <a:t># what is here, with sizes</a:t>
+              <a:t># list files</a:t>
             </a:r>
             <a:br/>
             <a:r>
               <a:rPr>
-                <a:solidFill>
-                  <a:srgbClr val="06287E"/>
-                </a:solidFill>
-                <a:latin typeface="Courier"/>
-              </a:rPr>
-              <a:t>mkdir</a:t>
-            </a:r>
-            <a:r>
-              <a:rPr>
-                <a:latin typeface="Courier"/>
-              </a:rPr>
-              <a:t> </a:t>
+                <a:latin typeface="Courier"/>
+              </a:rPr>
+              <a:t>$ ls </a:t>
             </a:r>
             <a:r>
               <a:rPr>
@@ -7052,14 +8223,9 @@
                 </a:solidFill>
                 <a:latin typeface="Courier"/>
               </a:rPr>
-              <a:t>-p</a:t>
-            </a:r>
-            <a:r>
-              <a:rPr>
-                <a:latin typeface="Courier"/>
-              </a:rPr>
-              <a:t> results/2026   </a:t>
-            </a:r>
+              <a:t>-lh</a:t>
+            </a:r>
+            <a:br/>
             <a:r>
               <a:rPr i="1">
                 <a:solidFill>
@@ -7067,24 +8233,31 @@
                 </a:solidFill>
                 <a:latin typeface="Courier"/>
               </a:rPr>
-              <a:t># make a folder (and its parents)</a:t>
+              <a:t># create a folder</a:t>
             </a:r>
             <a:br/>
             <a:r>
               <a:rPr>
+                <a:latin typeface="Courier"/>
+              </a:rPr>
+              <a:t>$ mkdir </a:t>
+            </a:r>
+            <a:r>
+              <a:rPr>
                 <a:solidFill>
-                  <a:srgbClr val="06287E"/>
+                  <a:srgbClr val="7D9029"/>
                 </a:solidFill>
                 <a:latin typeface="Courier"/>
               </a:rPr>
-              <a:t>cp</a:t>
-            </a:r>
-            <a:r>
-              <a:rPr>
-                <a:latin typeface="Courier"/>
-              </a:rPr>
-              <a:t> a.csv backup/        </a:t>
-            </a:r>
+              <a:t>-p</a:t>
+            </a:r>
+            <a:r>
+              <a:rPr>
+                <a:latin typeface="Courier"/>
+              </a:rPr>
+              <a:t> results/2026</a:t>
+            </a:r>
+            <a:br/>
             <a:r>
               <a:rPr i="1">
                 <a:solidFill>
@@ -7092,7 +8265,48 @@
                 </a:solidFill>
                 <a:latin typeface="Courier"/>
               </a:rPr>
-              <a:t># copy      (mv = move / rename, rm = delete)</a:t>
+              <a:t># copy</a:t>
+            </a:r>
+            <a:br/>
+            <a:r>
+              <a:rPr>
+                <a:latin typeface="Courier"/>
+              </a:rPr>
+              <a:t>$ cp a.csv backup_a.csv</a:t>
+            </a:r>
+            <a:br/>
+            <a:r>
+              <a:rPr i="1">
+                <a:solidFill>
+                  <a:srgbClr val="60A0B0"/>
+                </a:solidFill>
+                <a:latin typeface="Courier"/>
+              </a:rPr>
+              <a:t># move / rename</a:t>
+            </a:r>
+            <a:br/>
+            <a:r>
+              <a:rPr>
+                <a:latin typeface="Courier"/>
+              </a:rPr>
+              <a:t>$ mv a.csv new_a.csv</a:t>
+            </a:r>
+            <a:br/>
+            <a:r>
+              <a:rPr i="1">
+                <a:solidFill>
+                  <a:srgbClr val="60A0B0"/>
+                </a:solidFill>
+                <a:latin typeface="Courier"/>
+              </a:rPr>
+              <a:t># delete</a:t>
+            </a:r>
+            <a:br/>
+            <a:r>
+              <a:rPr>
+                <a:latin typeface="Courier"/>
+              </a:rPr>
+              <a:t>$ rm new_a.csv</a:t>
             </a:r>
           </a:p>
         </p:txBody>

</xml_diff>